<commit_message>
Apply writing guide across ART documents and pitch decks
</commit_message>
<xml_diff>
--- a/Denver/Common-Altitude-2027/decks/00-Creative-Direction.pptx
+++ b/Denver/Common-Altitude-2027/decks/00-Creative-Direction.pptx
@@ -524,7 +524,7 @@
           </a:p>
           <a:p>
             <a:r>
-              <a:t>Working creative direction / Denver 2027</a:t>
+              <a:t>Proposed Denver Art Fair &amp; Exhibition, 2027</a:t>
             </a:r>
           </a:p>
           <a:p/>
@@ -532,7 +532,7 @@
           <a:p/>
           <a:p>
             <a:r>
-              <a:t>Status: working proposal; site/date/partners/funding/capacities unconfirmed. No external action is authorized by the deck.</a:t>
+              <a:t>Status: working proposal. Site, dates, partners, funding and capacity need confirmation. The deck grants no external-action authority.</a:t>
             </a:r>
           </a:p>
           <a:p>
@@ -622,35 +622,35 @@
           </a:p>
           <a:p>
             <a:r>
-              <a:t>The ordinary becomes extraordinary.</a:t>
+              <a:t>Art in former offices</a:t>
             </a:r>
           </a:p>
           <a:p/>
           <a:p>
             <a:r>
-              <a:t>A remarkable place to discover and acquire art, open to the city.</a:t>
+              <a:t>Artists and galleries present work for sale alongside commissions and free public programs.</a:t>
             </a:r>
           </a:p>
           <a:p/>
           <a:p>
             <a:r>
-              <a:t>Artist authorship, a public welcome and a serious art market.</a:t>
-            </a:r>
-          </a:p>
-          <a:p>
-            <a:r>
-              <a:t>A familiar room can become an unexpected encounter.</a:t>
-            </a:r>
-          </a:p>
-          <a:p>
-            <a:r>
-              <a:t>The visitor experience should be as good as the headline idea.</a:t>
+              <a:t>Give each artist or gallery a defined space and control of their presentation.</a:t>
+            </a:r>
+          </a:p>
+          <a:p>
+            <a:r>
+              <a:t>Provide readable artwork records, buyer appointments and seller contacts.</a:t>
+            </a:r>
+          </a:p>
+          <a:p>
+            <a:r>
+              <a:t>Pay creative work and keep core public art discovery free.</a:t>
             </a:r>
           </a:p>
           <a:p/>
           <a:p>
             <a:r>
-              <a:t>Status: working proposal; site/date/partners/funding/capacities unconfirmed. No external action is authorized by the deck.</a:t>
+              <a:t>Status: working proposal. Site, dates, partners, funding and capacity need confirmation. The deck grants no external-action authority.</a:t>
             </a:r>
           </a:p>
           <a:p>
@@ -740,13 +740,13 @@
           </a:p>
           <a:p>
             <a:r>
-              <a:t>A precise interruption.</a:t>
+              <a:t>Ink, paper and two accent colors</a:t>
             </a:r>
           </a:p>
           <a:p/>
           <a:p>
             <a:r>
-              <a:t>Ink and paper establish calm. Citron and cobalt create a controlled moment of surprise.</a:t>
+              <a:t>Use ink and paper for reading. Citron and cobalt identify selected actions and programs.</a:t>
             </a:r>
           </a:p>
           <a:p/>
@@ -754,7 +754,7 @@
           <a:p/>
           <a:p>
             <a:r>
-              <a:t>Status: working proposal; site/date/partners/funding/capacities unconfirmed. No external action is authorized by the deck.</a:t>
+              <a:t>Status: working proposal. Site, dates, partners, funding and capacity need confirmation. The deck grants no external-action authority.</a:t>
             </a:r>
           </a:p>
           <a:p>
@@ -844,40 +844,40 @@
           </a:p>
           <a:p>
             <a:r>
-              <a:t>An open frame. A shared passage.</a:t>
+              <a:t>Two offset open frames</a:t>
             </a:r>
           </a:p>
           <a:p/>
           <a:p>
             <a:r>
-              <a:t>An original abstract identity device, not a drawing of the venue.</a:t>
+              <a:t>The original abstract mark suggests connected rooms. It contains no measured building plan.</a:t>
             </a:r>
           </a:p>
           <a:p/>
           <a:p>
             <a:r>
-              <a:t>A room, a threshold and a horizon.</a:t>
-            </a:r>
-          </a:p>
-          <a:p>
-            <a:r>
-              <a:t>Two structures in one coherent system.</a:t>
-            </a:r>
-          </a:p>
-          <a:p>
-            <a:r>
-              <a:t>Simple enough for a label; strong enough for a facade-scale concept.</a:t>
-            </a:r>
-          </a:p>
-          <a:p>
-            <a:r>
-              <a:t>Final name/mark clearance and production proofs remain required.</a:t>
+              <a:t>Preserve the offset frames and their proportions.</a:t>
+            </a:r>
+          </a:p>
+          <a:p>
+            <a:r>
+              <a:t>Use one-color versions on artwork labels and larger signs.</a:t>
+            </a:r>
+          </a:p>
+          <a:p>
+            <a:r>
+              <a:t>Test legibility at actual production sizes.</a:t>
+            </a:r>
+          </a:p>
+          <a:p>
+            <a:r>
+              <a:t>Clear the name and mark before public launch.</a:t>
             </a:r>
           </a:p>
           <a:p/>
           <a:p>
             <a:r>
-              <a:t>Status: working proposal; site/date/partners/funding/capacities unconfirmed. No external action is authorized by the deck.</a:t>
+              <a:t>Status: working proposal. Site, dates, partners, funding and capacity need confirmation. The deck grants no external-action authority.</a:t>
             </a:r>
           </a:p>
           <a:p>
@@ -967,40 +967,40 @@
           </a:p>
           <a:p>
             <a:r>
-              <a:t>A clear invitation.</a:t>
+              <a:t>Poster information and hierarchy</a:t>
             </a:r>
           </a:p>
           <a:p/>
           <a:p>
             <a:r>
-              <a:t>A concept application with honest proposed status, not a public event announcement.</a:t>
+              <a:t>The concept identifies the event. Dates, venue and participants still need confirmation.</a:t>
             </a:r>
           </a:p>
           <a:p/>
           <a:p>
             <a:r>
-              <a:t>Oversized short language.</a:t>
-            </a:r>
-          </a:p>
-          <a:p>
-            <a:r>
-              <a:t>A disciplined original graphic.</a:t>
-            </a:r>
-          </a:p>
-          <a:p>
-            <a:r>
-              <a:t>Practical information remains readable.</a:t>
-            </a:r>
-          </a:p>
-          <a:p>
-            <a:r>
-              <a:t>Artwork is credited evidence, never decorative stock.</a:t>
+              <a:t>State Denver Art Fair &amp; Exhibition.</a:t>
+            </a:r>
+          </a:p>
+          <a:p>
+            <a:r>
+              <a:t>Show the date and venue status clearly.</a:t>
+            </a:r>
+          </a:p>
+          <a:p>
+            <a:r>
+              <a:t>Keep access and free/paid information readable.</a:t>
+            </a:r>
+          </a:p>
+          <a:p>
+            <a:r>
+              <a:t>Credit art images and use them only with permission.</a:t>
             </a:r>
           </a:p>
           <a:p/>
           <a:p>
             <a:r>
-              <a:t>Status: working proposal; site/date/partners/funding/capacities unconfirmed. No external action is authorized by the deck.</a:t>
+              <a:t>Status: working proposal. Site, dates, partners, funding and capacity need confirmation. The deck grants no external-action authority.</a:t>
             </a:r>
           </a:p>
           <a:p>
@@ -1090,35 +1090,35 @@
           </a:p>
           <a:p>
             <a:r>
-              <a:t>One system. Many voices.</a:t>
+              <a:t>Three exhibition settings</a:t>
             </a:r>
           </a:p>
           <a:p/>
           <a:p>
             <a:r>
-              <a:t>The art leads; the system supplies coherence.</a:t>
+              <a:t>Keep the same type, colors and information rules across the program.</a:t>
             </a:r>
           </a:p>
           <a:p/>
           <a:p>
             <a:r>
-              <a:t>PRECISE / Editorial clarity, accurate information and serious service.</a:t>
-            </a:r>
-          </a:p>
-          <a:p>
-            <a:r>
-              <a:t>NOCTURNAL / Artist-led light/sound for specific approved programs.</a:t>
-            </a:r>
-          </a:p>
-          <a:p>
-            <a:r>
-              <a:t>MATERIAL / Hands, making and paid local authorship.</a:t>
+              <a:t>GALLERIES / Readable labels, full artwork views and quiet buying appointments.</a:t>
+            </a:r>
+          </a:p>
+          <a:p>
+            <a:r>
+              <a:t>MEDIA WORKS / Artist-led light and sound with approved access and operating limits.</a:t>
+            </a:r>
+          </a:p>
+          <a:p>
+            <a:r>
+              <a:t>WORKSHOPS / Paid artists lead making and learning with clear participant terms.</a:t>
             </a:r>
           </a:p>
           <a:p/>
           <a:p>
             <a:r>
-              <a:t>Status: working proposal; site/date/partners/funding/capacities unconfirmed. No external action is authorized by the deck.</a:t>
+              <a:t>Status: working proposal. Site, dates, partners, funding and capacity need confirmation. The deck grants no external-action authority.</a:t>
             </a:r>
           </a:p>
           <a:p>
@@ -1208,35 +1208,35 @@
           </a:p>
           <a:p>
             <a:r>
-              <a:t>Make the experience worthy of the art.</a:t>
+              <a:t>Brand review and design scope</a:t>
             </a:r>
           </a:p>
           <a:p/>
           <a:p>
             <a:r>
-              <a:t>Review the direction with artists, buyers, residents and disabled visitors; refine through funded design work.</a:t>
+              <a:t>Test the direction with artists, buyers, residents and disabled visitors. Fund the next design scope.</a:t>
             </a:r>
           </a:p>
           <a:p/>
           <a:p>
             <a:r>
-              <a:t>Keep authorship, rights and public welcome intact.</a:t>
-            </a:r>
-          </a:p>
-          <a:p>
-            <a:r>
-              <a:t>Choose achievable exceptional work over borrowed spectacle.</a:t>
-            </a:r>
-          </a:p>
-          <a:p>
-            <a:r>
-              <a:t>Use the brand book and production briefs as the working system.</a:t>
+              <a:t>Check whether visitors understand the event and next action.</a:t>
+            </a:r>
+          </a:p>
+          <a:p>
+            <a:r>
+              <a:t>Test type, color, images and signs at actual sizes.</a:t>
+            </a:r>
+          </a:p>
+          <a:p>
+            <a:r>
+              <a:t>Record changes and approval before public production.</a:t>
             </a:r>
           </a:p>
           <a:p/>
           <a:p>
             <a:r>
-              <a:t>Status: working proposal; site/date/partners/funding/capacities unconfirmed. No external action is authorized by the deck.</a:t>
+              <a:t>Status: working proposal. Site, dates, partners, funding and capacity need confirmation. The deck grants no external-action authority.</a:t>
             </a:r>
           </a:p>
           <a:p>
@@ -4439,7 +4439,7 @@
               </a:defRPr>
             </a:pPr>
             <a:r>
-              <a:t>Working creative direction / Denver 2027</a:t>
+              <a:t>Proposed Denver Art Fair &amp; Exhibition, 2027</a:t>
             </a:r>
           </a:p>
         </p:txBody>
@@ -5122,29 +5122,7 @@
               </a:defRPr>
             </a:pPr>
             <a:r>
-              <a:t>The ordinary becomes</a:t>
-            </a:r>
-          </a:p>
-          <a:p>
-            <a:pPr>
-              <a:lnSpc>
-                <a:spcPct val="108000"/>
-              </a:lnSpc>
-              <a:spcBef>
-                <a:spcPts val="0"/>
-              </a:spcBef>
-              <a:spcAft>
-                <a:spcPts val="0"/>
-              </a:spcAft>
-              <a:defRPr sz="5000" b="1">
-                <a:solidFill>
-                  <a:srgbClr val="151A22"/>
-                </a:solidFill>
-                <a:latin typeface="Arial"/>
-              </a:defRPr>
-            </a:pPr>
-            <a:r>
-              <a:t>extraordinary.</a:t>
+              <a:t>Art in former offices</a:t>
             </a:r>
           </a:p>
         </p:txBody>
@@ -5157,7 +5135,7 @@
         </p:nvSpPr>
         <p:spPr>
           <a:xfrm>
-            <a:off x="914400" y="2585720"/>
+            <a:off x="914400" y="1887220"/>
             <a:ext cx="12618720" cy="1005840"/>
           </a:xfrm>
           <a:prstGeom prst="rect">
@@ -5189,7 +5167,7 @@
               </a:defRPr>
             </a:pPr>
             <a:r>
-              <a:t>A remarkable place to discover and acquire art, open to the city.</a:t>
+              <a:t>Artists and galleries present work for sale alongside commissions and free public programs.</a:t>
             </a:r>
           </a:p>
         </p:txBody>
@@ -5202,7 +5180,7 @@
         </p:nvSpPr>
         <p:spPr>
           <a:xfrm>
-            <a:off x="914400" y="3217926"/>
+            <a:off x="914400" y="2880360"/>
             <a:ext cx="68580" cy="457200"/>
           </a:xfrm>
           <a:prstGeom prst="rect">
@@ -5245,8 +5223,8 @@
         </p:nvSpPr>
         <p:spPr>
           <a:xfrm>
-            <a:off x="1234440" y="3190494"/>
-            <a:ext cx="12252960" cy="1265173"/>
+            <a:off x="1234440" y="2852928"/>
+            <a:ext cx="12252960" cy="1377695"/>
           </a:xfrm>
           <a:prstGeom prst="rect">
             <a:avLst/>
@@ -5277,7 +5255,7 @@
               </a:defRPr>
             </a:pPr>
             <a:r>
-              <a:t>Artist authorship, a public welcome and a serious art market.</a:t>
+              <a:t>Give each artist or gallery a defined space and control of their presentation.</a:t>
             </a:r>
           </a:p>
         </p:txBody>
@@ -5290,7 +5268,7 @@
         </p:nvSpPr>
         <p:spPr>
           <a:xfrm>
-            <a:off x="914400" y="4601972"/>
+            <a:off x="914400" y="4376928"/>
             <a:ext cx="68580" cy="457200"/>
           </a:xfrm>
           <a:prstGeom prst="rect">
@@ -5333,8 +5311,8 @@
         </p:nvSpPr>
         <p:spPr>
           <a:xfrm>
-            <a:off x="1234440" y="4574540"/>
-            <a:ext cx="12252960" cy="1265173"/>
+            <a:off x="1234440" y="4349496"/>
+            <a:ext cx="12252960" cy="1377695"/>
           </a:xfrm>
           <a:prstGeom prst="rect">
             <a:avLst/>
@@ -5365,7 +5343,7 @@
               </a:defRPr>
             </a:pPr>
             <a:r>
-              <a:t>A familiar room can become an unexpected encounter.</a:t>
+              <a:t>Provide readable artwork records, buyer appointments and seller contacts.</a:t>
             </a:r>
           </a:p>
         </p:txBody>
@@ -5378,7 +5356,7 @@
         </p:nvSpPr>
         <p:spPr>
           <a:xfrm>
-            <a:off x="914400" y="5986018"/>
+            <a:off x="914400" y="5873496"/>
             <a:ext cx="68580" cy="457200"/>
           </a:xfrm>
           <a:prstGeom prst="rect">
@@ -5421,8 +5399,8 @@
         </p:nvSpPr>
         <p:spPr>
           <a:xfrm>
-            <a:off x="1234440" y="5958586"/>
-            <a:ext cx="12252960" cy="1265173"/>
+            <a:off x="1234440" y="5846063"/>
+            <a:ext cx="12252960" cy="1377695"/>
           </a:xfrm>
           <a:prstGeom prst="rect">
             <a:avLst/>
@@ -5453,7 +5431,7 @@
               </a:defRPr>
             </a:pPr>
             <a:r>
-              <a:t>The visitor experience should be as good as the headline idea.</a:t>
+              <a:t>Pay creative work and keep core public art discovery free.</a:t>
             </a:r>
           </a:p>
         </p:txBody>
@@ -5747,7 +5725,7 @@
               </a:defRPr>
             </a:pPr>
             <a:r>
-              <a:t>A precise interruption.</a:t>
+              <a:t>Ink, paper and two accent colors</a:t>
             </a:r>
           </a:p>
         </p:txBody>
@@ -5792,7 +5770,7 @@
               </a:defRPr>
             </a:pPr>
             <a:r>
-              <a:t>Ink and paper establish calm. Citron and cobalt create a controlled moment of surprise.</a:t>
+              <a:t>Use ink and paper for reading. Citron and cobalt identify selected actions and programs.</a:t>
             </a:r>
           </a:p>
         </p:txBody>
@@ -6751,29 +6729,7 @@
               </a:defRPr>
             </a:pPr>
             <a:r>
-              <a:t>An open frame.</a:t>
-            </a:r>
-          </a:p>
-          <a:p>
-            <a:pPr>
-              <a:lnSpc>
-                <a:spcPct val="108000"/>
-              </a:lnSpc>
-              <a:spcBef>
-                <a:spcPts val="0"/>
-              </a:spcBef>
-              <a:spcAft>
-                <a:spcPts val="0"/>
-              </a:spcAft>
-              <a:defRPr sz="5000" b="1">
-                <a:solidFill>
-                  <a:srgbClr val="151A22"/>
-                </a:solidFill>
-                <a:latin typeface="Arial"/>
-              </a:defRPr>
-            </a:pPr>
-            <a:r>
-              <a:t>A shared passage.</a:t>
+              <a:t>Two offset open frames</a:t>
             </a:r>
           </a:p>
         </p:txBody>
@@ -6786,7 +6742,7 @@
         </p:nvSpPr>
         <p:spPr>
           <a:xfrm>
-            <a:off x="914400" y="2585720"/>
+            <a:off x="914400" y="1887220"/>
             <a:ext cx="12618720" cy="1005840"/>
           </a:xfrm>
           <a:prstGeom prst="rect">
@@ -6818,7 +6774,7 @@
               </a:defRPr>
             </a:pPr>
             <a:r>
-              <a:t>An original abstract identity device, not a drawing of the venue.</a:t>
+              <a:t>The original abstract mark suggests connected rooms. It contains no measured building plan.</a:t>
             </a:r>
           </a:p>
         </p:txBody>
@@ -6831,8 +6787,8 @@
         </p:nvSpPr>
         <p:spPr>
           <a:xfrm>
-            <a:off x="1872544" y="3190494"/>
-            <a:ext cx="2043785" cy="79480"/>
+            <a:off x="1747520" y="2852928"/>
+            <a:ext cx="2223820" cy="86481"/>
           </a:xfrm>
           <a:prstGeom prst="rect">
             <a:avLst/>
@@ -6874,8 +6830,8 @@
         </p:nvSpPr>
         <p:spPr>
           <a:xfrm>
-            <a:off x="1872544" y="3190494"/>
-            <a:ext cx="79480" cy="3065678"/>
+            <a:off x="1747520" y="2852928"/>
+            <a:ext cx="86481" cy="3335731"/>
           </a:xfrm>
           <a:prstGeom prst="rect">
             <a:avLst/>
@@ -6917,8 +6873,8 @@
         </p:nvSpPr>
         <p:spPr>
           <a:xfrm>
-            <a:off x="3836849" y="3190494"/>
-            <a:ext cx="79480" cy="1992690"/>
+            <a:off x="3884858" y="2852928"/>
+            <a:ext cx="86481" cy="2168225"/>
           </a:xfrm>
           <a:prstGeom prst="rect">
             <a:avLst/>
@@ -6960,8 +6916,8 @@
         </p:nvSpPr>
         <p:spPr>
           <a:xfrm>
-            <a:off x="2667349" y="3956913"/>
-            <a:ext cx="2043785" cy="79480"/>
+            <a:off x="2612339" y="3686860"/>
+            <a:ext cx="2223820" cy="86481"/>
           </a:xfrm>
           <a:prstGeom prst="rect">
             <a:avLst/>
@@ -7003,8 +6959,8 @@
         </p:nvSpPr>
         <p:spPr>
           <a:xfrm>
-            <a:off x="2667349" y="3956913"/>
-            <a:ext cx="79480" cy="3065678"/>
+            <a:off x="2612339" y="3686860"/>
+            <a:ext cx="86481" cy="3335731"/>
           </a:xfrm>
           <a:prstGeom prst="rect">
             <a:avLst/>
@@ -7046,8 +7002,8 @@
         </p:nvSpPr>
         <p:spPr>
           <a:xfrm>
-            <a:off x="4631655" y="3956913"/>
-            <a:ext cx="79480" cy="3065678"/>
+            <a:off x="4749678" y="3686860"/>
+            <a:ext cx="86481" cy="3335731"/>
           </a:xfrm>
           <a:prstGeom prst="rect">
             <a:avLst/>
@@ -7089,8 +7045,8 @@
         </p:nvSpPr>
         <p:spPr>
           <a:xfrm>
-            <a:off x="2667349" y="6943111"/>
-            <a:ext cx="2043785" cy="79480"/>
+            <a:off x="2612339" y="6936110"/>
+            <a:ext cx="2223820" cy="86481"/>
           </a:xfrm>
           <a:prstGeom prst="rect">
             <a:avLst/>
@@ -7132,8 +7088,8 @@
         </p:nvSpPr>
         <p:spPr>
           <a:xfrm>
-            <a:off x="1872544" y="6176691"/>
-            <a:ext cx="1362523" cy="79480"/>
+            <a:off x="1747520" y="6102177"/>
+            <a:ext cx="1482547" cy="86481"/>
           </a:xfrm>
           <a:prstGeom prst="rect">
             <a:avLst/>
@@ -7175,7 +7131,7 @@
         </p:nvSpPr>
         <p:spPr>
           <a:xfrm>
-            <a:off x="7315200" y="3190494"/>
+            <a:off x="7315200" y="2852928"/>
             <a:ext cx="6035040" cy="777240"/>
           </a:xfrm>
           <a:prstGeom prst="rect">
@@ -7207,7 +7163,7 @@
               </a:defRPr>
             </a:pPr>
             <a:r>
-              <a:t>A room, a threshold and a horizon.</a:t>
+              <a:t>Preserve the offset frames and their proportions.</a:t>
             </a:r>
           </a:p>
         </p:txBody>
@@ -7220,7 +7176,7 @@
         </p:nvSpPr>
         <p:spPr>
           <a:xfrm>
-            <a:off x="7315200" y="4150614"/>
+            <a:off x="7315200" y="3813048"/>
             <a:ext cx="6035040" cy="777240"/>
           </a:xfrm>
           <a:prstGeom prst="rect">
@@ -7252,32 +7208,9 @@
               </a:defRPr>
             </a:pPr>
             <a:r>
-              <a:t>Two structures in one coherent system.</a:t>
-            </a:r>
-          </a:p>
-        </p:txBody>
-      </p:sp>
-      <p:sp>
-        <p:nvSpPr>
-          <p:cNvPr id="15" name="TextBox 14"/>
-          <p:cNvSpPr txBox="1"/>
-          <p:nvPr/>
-        </p:nvSpPr>
-        <p:spPr>
-          <a:xfrm>
-            <a:off x="7315200" y="5110734"/>
-            <a:ext cx="6035040" cy="777240"/>
-          </a:xfrm>
-          <a:prstGeom prst="rect">
-            <a:avLst/>
-          </a:prstGeom>
-          <a:noFill/>
-        </p:spPr>
-        <p:txBody>
-          <a:bodyPr wrap="none" lIns="0" rIns="0" tIns="0" bIns="0" anchor="t">
-            <a:spAutoFit/>
-          </a:bodyPr>
-          <a:lstStyle/>
+              <a:t>Use one-color versions on artwork labels and</a:t>
+            </a:r>
+          </a:p>
           <a:p>
             <a:pPr>
               <a:lnSpc>
@@ -7297,9 +7230,32 @@
               </a:defRPr>
             </a:pPr>
             <a:r>
-              <a:t>Simple enough for a label; strong enough for a</a:t>
-            </a:r>
-          </a:p>
+              <a:t>larger signs.</a:t>
+            </a:r>
+          </a:p>
+        </p:txBody>
+      </p:sp>
+      <p:sp>
+        <p:nvSpPr>
+          <p:cNvPr id="15" name="TextBox 14"/>
+          <p:cNvSpPr txBox="1"/>
+          <p:nvPr/>
+        </p:nvSpPr>
+        <p:spPr>
+          <a:xfrm>
+            <a:off x="7315200" y="4773168"/>
+            <a:ext cx="6035040" cy="777240"/>
+          </a:xfrm>
+          <a:prstGeom prst="rect">
+            <a:avLst/>
+          </a:prstGeom>
+          <a:noFill/>
+        </p:spPr>
+        <p:txBody>
+          <a:bodyPr wrap="none" lIns="0" rIns="0" tIns="0" bIns="0" anchor="t">
+            <a:spAutoFit/>
+          </a:bodyPr>
+          <a:lstStyle/>
           <a:p>
             <a:pPr>
               <a:lnSpc>
@@ -7319,7 +7275,7 @@
               </a:defRPr>
             </a:pPr>
             <a:r>
-              <a:t>facade-scale concept.</a:t>
+              <a:t>Test legibility at actual production sizes.</a:t>
             </a:r>
           </a:p>
         </p:txBody>
@@ -7332,7 +7288,7 @@
         </p:nvSpPr>
         <p:spPr>
           <a:xfrm>
-            <a:off x="7315200" y="6070854"/>
+            <a:off x="7315200" y="5733288"/>
             <a:ext cx="6035040" cy="777240"/>
           </a:xfrm>
           <a:prstGeom prst="rect">
@@ -7364,29 +7320,7 @@
               </a:defRPr>
             </a:pPr>
             <a:r>
-              <a:t>Final name/mark clearance and production</a:t>
-            </a:r>
-          </a:p>
-          <a:p>
-            <a:pPr>
-              <a:lnSpc>
-                <a:spcPct val="108000"/>
-              </a:lnSpc>
-              <a:spcBef>
-                <a:spcPts val="0"/>
-              </a:spcBef>
-              <a:spcAft>
-                <a:spcPts val="0"/>
-              </a:spcAft>
-              <a:defRPr sz="2200" b="0">
-                <a:solidFill>
-                  <a:srgbClr val="151A22"/>
-                </a:solidFill>
-                <a:latin typeface="Arial"/>
-              </a:defRPr>
-            </a:pPr>
-            <a:r>
-              <a:t>proofs remain required.</a:t>
+              <a:t>Clear the name and mark before public launch.</a:t>
             </a:r>
           </a:p>
         </p:txBody>
@@ -7680,7 +7614,7 @@
               </a:defRPr>
             </a:pPr>
             <a:r>
-              <a:t>A clear invitation.</a:t>
+              <a:t>Poster information and hierarchy</a:t>
             </a:r>
           </a:p>
         </p:txBody>
@@ -7725,7 +7659,7 @@
               </a:defRPr>
             </a:pPr>
             <a:r>
-              <a:t>A concept application with honest proposed status, not a public event announcement.</a:t>
+              <a:t>The concept identifies the event. Dates, venue and participants still need confirmation.</a:t>
             </a:r>
           </a:p>
         </p:txBody>
@@ -7813,7 +7747,7 @@
               </a:defRPr>
             </a:pPr>
             <a:r>
-              <a:t>ART IS</a:t>
+              <a:t>DENVER</a:t>
             </a:r>
           </a:p>
           <a:p>
@@ -7835,29 +7769,7 @@
               </a:defRPr>
             </a:pPr>
             <a:r>
-              <a:t>TAKING</a:t>
-            </a:r>
-          </a:p>
-          <a:p>
-            <a:pPr>
-              <a:lnSpc>
-                <a:spcPct val="108000"/>
-              </a:lnSpc>
-              <a:spcBef>
-                <a:spcPts val="0"/>
-              </a:spcBef>
-              <a:spcAft>
-                <a:spcPts val="0"/>
-              </a:spcAft>
-              <a:defRPr sz="3100" b="1">
-                <a:solidFill>
-                  <a:srgbClr val="DCFF5F"/>
-                </a:solidFill>
-                <a:latin typeface="Arial"/>
-              </a:defRPr>
-            </a:pPr>
-            <a:r>
-              <a:t>OVER.</a:t>
+              <a:t>ART FAIR</a:t>
             </a:r>
           </a:p>
         </p:txBody>
@@ -7969,7 +7881,7 @@
               </a:defRPr>
             </a:pPr>
             <a:r>
-              <a:t>Oversized short language.</a:t>
+              <a:t>State Denver Art Fair &amp; Exhibition.</a:t>
             </a:r>
           </a:p>
         </p:txBody>
@@ -8014,7 +7926,7 @@
               </a:defRPr>
             </a:pPr>
             <a:r>
-              <a:t>A disciplined original graphic.</a:t>
+              <a:t>Show the date and venue status clearly.</a:t>
             </a:r>
           </a:p>
         </p:txBody>
@@ -8059,7 +7971,7 @@
               </a:defRPr>
             </a:pPr>
             <a:r>
-              <a:t>Practical information remains readable.</a:t>
+              <a:t>Keep access and free/paid information readable.</a:t>
             </a:r>
           </a:p>
         </p:txBody>
@@ -8104,7 +8016,7 @@
               </a:defRPr>
             </a:pPr>
             <a:r>
-              <a:t>Artwork is credited evidence, never decorative stock.</a:t>
+              <a:t>Credit art images and use them only with permission.</a:t>
             </a:r>
           </a:p>
         </p:txBody>
@@ -8398,7 +8310,7 @@
               </a:defRPr>
             </a:pPr>
             <a:r>
-              <a:t>One system. Many voices.</a:t>
+              <a:t>Three exhibition settings</a:t>
             </a:r>
           </a:p>
         </p:txBody>
@@ -8443,7 +8355,7 @@
               </a:defRPr>
             </a:pPr>
             <a:r>
-              <a:t>The art leads; the system supplies coherence.</a:t>
+              <a:t>Keep the same type, colors and information rules across the program.</a:t>
             </a:r>
           </a:p>
         </p:txBody>
@@ -8574,7 +8486,7 @@
               </a:defRPr>
             </a:pPr>
             <a:r>
-              <a:t>PRECISE</a:t>
+              <a:t>GALLERIES</a:t>
             </a:r>
           </a:p>
         </p:txBody>
@@ -8619,7 +8531,7 @@
               </a:defRPr>
             </a:pPr>
             <a:r>
-              <a:t>Editorial clarity, accurate</a:t>
+              <a:t>Readable labels, full artwork</a:t>
             </a:r>
           </a:p>
           <a:p>
@@ -8641,7 +8553,7 @@
               </a:defRPr>
             </a:pPr>
             <a:r>
-              <a:t>information and serious</a:t>
+              <a:t>views and quiet buying</a:t>
             </a:r>
           </a:p>
           <a:p>
@@ -8663,7 +8575,7 @@
               </a:defRPr>
             </a:pPr>
             <a:r>
-              <a:t>service.</a:t>
+              <a:t>appointments.</a:t>
             </a:r>
           </a:p>
         </p:txBody>
@@ -8794,7 +8706,7 @@
               </a:defRPr>
             </a:pPr>
             <a:r>
-              <a:t>NOCTURNAL</a:t>
+              <a:t>MEDIA WORKS</a:t>
             </a:r>
           </a:p>
         </p:txBody>
@@ -8839,7 +8751,7 @@
               </a:defRPr>
             </a:pPr>
             <a:r>
-              <a:t>Artist-led light/sound for</a:t>
+              <a:t>Artist-led light and sound with</a:t>
             </a:r>
           </a:p>
           <a:p>
@@ -8861,7 +8773,29 @@
               </a:defRPr>
             </a:pPr>
             <a:r>
-              <a:t>specific approved programs.</a:t>
+              <a:t>approved access and</a:t>
+            </a:r>
+          </a:p>
+          <a:p>
+            <a:pPr>
+              <a:lnSpc>
+                <a:spcPct val="108000"/>
+              </a:lnSpc>
+              <a:spcBef>
+                <a:spcPts val="0"/>
+              </a:spcBef>
+              <a:spcAft>
+                <a:spcPts val="0"/>
+              </a:spcAft>
+              <a:defRPr sz="2100" b="0">
+                <a:solidFill>
+                  <a:srgbClr val="151A22"/>
+                </a:solidFill>
+                <a:latin typeface="Arial"/>
+              </a:defRPr>
+            </a:pPr>
+            <a:r>
+              <a:t>operating limits.</a:t>
             </a:r>
           </a:p>
         </p:txBody>
@@ -8992,7 +8926,7 @@
               </a:defRPr>
             </a:pPr>
             <a:r>
-              <a:t>MATERIAL</a:t>
+              <a:t>WORKSHOPS</a:t>
             </a:r>
           </a:p>
         </p:txBody>
@@ -9037,7 +8971,7 @@
               </a:defRPr>
             </a:pPr>
             <a:r>
-              <a:t>Hands, making and paid local</a:t>
+              <a:t>Paid artists lead making and</a:t>
             </a:r>
           </a:p>
           <a:p>
@@ -9059,7 +8993,29 @@
               </a:defRPr>
             </a:pPr>
             <a:r>
-              <a:t>authorship.</a:t>
+              <a:t>learning with clear participant</a:t>
+            </a:r>
+          </a:p>
+          <a:p>
+            <a:pPr>
+              <a:lnSpc>
+                <a:spcPct val="108000"/>
+              </a:lnSpc>
+              <a:spcBef>
+                <a:spcPts val="0"/>
+              </a:spcBef>
+              <a:spcAft>
+                <a:spcPts val="0"/>
+              </a:spcAft>
+              <a:defRPr sz="2100" b="0">
+                <a:solidFill>
+                  <a:srgbClr val="151A22"/>
+                </a:solidFill>
+                <a:latin typeface="Arial"/>
+              </a:defRPr>
+            </a:pPr>
+            <a:r>
+              <a:t>terms.</a:t>
             </a:r>
           </a:p>
         </p:txBody>
@@ -9353,7 +9309,7 @@
               </a:defRPr>
             </a:pPr>
             <a:r>
-              <a:t>Make the experience</a:t>
+              <a:t>Brand review and design</a:t>
             </a:r>
           </a:p>
           <a:p>
@@ -9375,7 +9331,7 @@
               </a:defRPr>
             </a:pPr>
             <a:r>
-              <a:t>worthy of the art.</a:t>
+              <a:t>scope</a:t>
             </a:r>
           </a:p>
         </p:txBody>
@@ -9420,7 +9376,7 @@
               </a:defRPr>
             </a:pPr>
             <a:r>
-              <a:t>Review the direction with artists, buyers, residents and disabled visitors;</a:t>
+              <a:t>Test the direction with artists, buyers, residents and disabled visitors.</a:t>
             </a:r>
           </a:p>
           <a:p>
@@ -9442,7 +9398,7 @@
               </a:defRPr>
             </a:pPr>
             <a:r>
-              <a:t>refine through funded design work.</a:t>
+              <a:t>Fund the next design scope.</a:t>
             </a:r>
           </a:p>
         </p:txBody>
@@ -9530,7 +9486,7 @@
               </a:defRPr>
             </a:pPr>
             <a:r>
-              <a:t>Keep authorship, rights and public welcome intact.</a:t>
+              <a:t>Check whether visitors understand the event and next action.</a:t>
             </a:r>
           </a:p>
         </p:txBody>
@@ -9618,7 +9574,7 @@
               </a:defRPr>
             </a:pPr>
             <a:r>
-              <a:t>Choose achievable exceptional work over borrowed spectacle.</a:t>
+              <a:t>Test type, color, images and signs at actual sizes.</a:t>
             </a:r>
           </a:p>
         </p:txBody>
@@ -9706,7 +9662,7 @@
               </a:defRPr>
             </a:pPr>
             <a:r>
-              <a:t>Use the brand book and production briefs as the working system.</a:t>
+              <a:t>Record changes and approval before public production.</a:t>
             </a:r>
           </a:p>
         </p:txBody>

</xml_diff>